<commit_message>
Convenios: presentacion municipios actualizada (precio nuevo) + PDF; recontactos enviados y borradores de gremios en la base
- Presentacion municipal: elimina modelo viejo 40/60, precios finales con
  descuento incluido (mercado 1.050.000 / con lente 1.000.000 / sin lente 850.000).
- Nuevo PDF de la presentacion (marca Lazarte, Manrope, 12 slides).
- Base de contactos: 14 recontactos marcados como enviados 23/09 (Geanet respondio);
  3 gremios con obra social propia como 'borrador a revisar' (UOM, Luz y Fuerza,
  Camioneros) con emails; AGEC pendiente de relevar.
- PANEL y estado-contactos actualizados.

Co-Authored-By: Claude Opus 4.8 <noreply@anthropic.com>
Claude-Session: https://claude.ai/code/session_01U3j1dNGqU3Tn9zZdTWjv1s
</commit_message>
<xml_diff>
--- a/convenios/ver-para-vivir/fuentes/Presentacion_Programa_Salud_Visual_Municipios.pptx
+++ b/convenios/ver-para-vivir/fuentes/Presentacion_Programa_Salud_Visual_Municipios.pptx
@@ -2311,7 +2311,7 @@
                 <a:ea typeface="Calibri" pitchFamily="34" charset="-122"/>
                 <a:cs typeface="Calibri" pitchFamily="34" charset="-120"/>
               </a:rPr>
-              <a:t>Un modelo de cofinanciamiento entre el municipio y un centro oftalmológico para operar cataratas y prevenir la ceguera evitable en personas sin cobertura.</a:t>
+              <a:t>Un convenio de precios preferenciales entre el municipio y un centro oftalmológico para operar cataratas y prevenir la ceguera evitable en personas sin cobertura.</a:t>
             </a:r>
             <a:endParaRPr lang="en-US" sz="1550" dirty="0"/>
           </a:p>
@@ -5266,7 +5266,7 @@
                 <a:ea typeface="Cambria" pitchFamily="34" charset="-122"/>
                 <a:cs typeface="Cambria" pitchFamily="34" charset="-120"/>
               </a:rPr>
-              <a:t>Cofinanciamiento: el Centro bonifica, el Municipio paga el saldo, el vecino se opera gratis</a:t>
+              <a:t>Precio preferencial: el Centro incluye el descuento, el Municipio paga el valor final, el vecino se opera gratis</a:t>
             </a:r>
             <a:endParaRPr lang="en-US" sz="2500" dirty="0"/>
           </a:p>
@@ -5376,7 +5376,7 @@
                 <a:ea typeface="Cambria" pitchFamily="34" charset="-122"/>
                 <a:cs typeface="Cambria" pitchFamily="34" charset="-120"/>
               </a:rPr>
-              <a:t>40%</a:t>
+              <a:t>Descuento</a:t>
             </a:r>
             <a:endParaRPr lang="en-US" sz="3400" dirty="0"/>
           </a:p>
@@ -5415,7 +5415,7 @@
                 <a:ea typeface="Calibri" pitchFamily="34" charset="-122"/>
                 <a:cs typeface="Calibri" pitchFamily="34" charset="-120"/>
               </a:rPr>
-              <a:t>El Centro bonifica</a:t>
+              <a:t>El Centro aplica</a:t>
             </a:r>
             <a:endParaRPr lang="en-US" sz="1500" dirty="0"/>
           </a:p>
@@ -5457,7 +5457,7 @@
                 <a:ea typeface="Calibri" pitchFamily="34" charset="-122"/>
                 <a:cs typeface="Calibri" pitchFamily="34" charset="-120"/>
               </a:rPr>
-              <a:t>Absorbe una parte del valor de cada práctica como aporte al programa.</a:t>
+              <a:t>Incluye el descuento del Programa en el precio de cada práctica.</a:t>
             </a:r>
             <a:endParaRPr lang="en-US" sz="1250" dirty="0"/>
           </a:p>
@@ -5567,7 +5567,7 @@
                 <a:ea typeface="Cambria" pitchFamily="34" charset="-122"/>
                 <a:cs typeface="Cambria" pitchFamily="34" charset="-120"/>
               </a:rPr>
-              <a:t>60%</a:t>
+              <a:t>Precio final</a:t>
             </a:r>
             <a:endParaRPr lang="en-US" sz="3400" dirty="0"/>
           </a:p>
@@ -5648,7 +5648,7 @@
                 <a:ea typeface="Calibri" pitchFamily="34" charset="-122"/>
                 <a:cs typeface="Calibri" pitchFamily="34" charset="-120"/>
               </a:rPr>
-              <a:t>Paga el saldo de prestaciones concretas realizadas a sus vecinos.</a:t>
+              <a:t>Paga el valor final de las prestaciones realizadas a sus vecinos.</a:t>
             </a:r>
             <a:endParaRPr lang="en-US" sz="1250" dirty="0"/>
           </a:p>
@@ -5878,7 +5878,7 @@
                 <a:ea typeface="Calibri" pitchFamily="34" charset="-122"/>
                 <a:cs typeface="Calibri" pitchFamily="34" charset="-120"/>
               </a:rPr>
-              <a:t>Los porcentajes son ilustrativos: 40/60, 50/50 u otra proporción. Lo que importa jurídicamente no es el porcentaje, sino el diseño.</a:t>
+              <a:t>Los valores son precios finales, con el descuento del Programa ya incluido. Lo que importa jurídicamente es el diseño transparente y auditable.</a:t>
             </a:r>
             <a:endParaRPr lang="en-US" sz="1300" dirty="0"/>
           </a:p>
@@ -8869,7 +8869,7 @@
                 <a:ea typeface="Calibri" pitchFamily="34" charset="-122"/>
                 <a:cs typeface="Calibri" pitchFamily="34" charset="-120"/>
               </a:rPr>
-              <a:t>Se paga el saldo contra factura con la bonificación consignada.</a:t>
+              <a:t>Se paga el valor final contra factura, al precio del Programa (descuento incluido).</a:t>
             </a:r>
             <a:endParaRPr lang="en-US" sz="1100" dirty="0"/>
           </a:p>
@@ -9138,7 +9138,7 @@
                 <a:ea typeface="Calibri" pitchFamily="34" charset="-122"/>
                 <a:cs typeface="Calibri" pitchFamily="34" charset="-120"/>
               </a:rPr>
-              <a:t>Ejemplo por cirugía (hipótesis)</a:t>
+              <a:t>Cirugía de catarata — precios del Programa</a:t>
             </a:r>
             <a:endParaRPr lang="en-US" sz="1400" dirty="0"/>
           </a:p>
@@ -9199,7 +9199,7 @@
                 <a:ea typeface="Calibri" pitchFamily="34" charset="-122"/>
                 <a:cs typeface="Calibri" pitchFamily="34" charset="-120"/>
               </a:rPr>
-              <a:t>Valor de referencia</a:t>
+              <a:t>Valor de mercado (ref.)</a:t>
             </a:r>
             <a:endParaRPr lang="en-US" sz="1350" dirty="0"/>
           </a:p>
@@ -9238,7 +9238,7 @@
                 <a:ea typeface="Cambria" pitchFamily="34" charset="-122"/>
                 <a:cs typeface="Cambria" pitchFamily="34" charset="-120"/>
               </a:rPr>
-              <a:t>$ 1.000.000</a:t>
+              <a:t>$ 1.050.000</a:t>
             </a:r>
             <a:endParaRPr lang="en-US" sz="1500" dirty="0"/>
           </a:p>
@@ -9299,7 +9299,7 @@
                 <a:ea typeface="Calibri" pitchFamily="34" charset="-122"/>
                 <a:cs typeface="Calibri" pitchFamily="34" charset="-120"/>
               </a:rPr>
-              <a:t>Bonificación del Centro (40%)</a:t>
+              <a:t>Precio Programa — con lente</a:t>
             </a:r>
             <a:endParaRPr lang="en-US" sz="1350" dirty="0"/>
           </a:p>
@@ -9338,7 +9338,7 @@
                 <a:ea typeface="Cambria" pitchFamily="34" charset="-122"/>
                 <a:cs typeface="Cambria" pitchFamily="34" charset="-120"/>
               </a:rPr>
-              <a:t>– $ 400.000</a:t>
+              <a:t>$ 1.000.000</a:t>
             </a:r>
             <a:endParaRPr lang="en-US" sz="1500" dirty="0"/>
           </a:p>
@@ -9399,7 +9399,7 @@
                 <a:ea typeface="Calibri" pitchFamily="34" charset="-122"/>
                 <a:cs typeface="Calibri" pitchFamily="34" charset="-120"/>
               </a:rPr>
-              <a:t>A cargo del Municipio (60%)</a:t>
+              <a:t>Precio Programa — sin lente</a:t>
             </a:r>
             <a:endParaRPr lang="en-US" sz="1350" dirty="0"/>
           </a:p>
@@ -9438,7 +9438,7 @@
                 <a:ea typeface="Cambria" pitchFamily="34" charset="-122"/>
                 <a:cs typeface="Cambria" pitchFamily="34" charset="-120"/>
               </a:rPr>
-              <a:t>$ 600.000</a:t>
+              <a:t>$ 850.000</a:t>
             </a:r>
             <a:endParaRPr lang="en-US" sz="1500" dirty="0"/>
           </a:p>
@@ -9580,7 +9580,7 @@
                 <a:ea typeface="Calibri" pitchFamily="34" charset="-122"/>
                 <a:cs typeface="Calibri" pitchFamily="34" charset="-120"/>
               </a:rPr>
-              <a:t>El costo unitario para el erario es menor que el valor de mercado: el gasto se justifica como eficiente.</a:t>
+              <a:t>Precios finales con el descuento del Programa ya incluido. Con lente: $1.000.000 el 1.er ojo y $850.000 el 2.º ojo. Sin lente: $850.000 (lente a cargo del paciente).</a:t>
             </a:r>
             <a:endParaRPr lang="en-US" sz="1250" dirty="0"/>
           </a:p>
@@ -10234,7 +10234,7 @@
                 <a:ea typeface="Calibri" pitchFamily="34" charset="-122"/>
                 <a:cs typeface="Calibri" pitchFamily="34" charset="-120"/>
               </a:rPr>
-              <a:t>Elegibilidad, autorización, consentimiento, práctica, factura con bonificación e informe médico.</a:t>
+              <a:t>Elegibilidad, autorización, consentimiento, práctica, factura al precio del Programa e informe médico.</a:t>
             </a:r>
             <a:endParaRPr lang="en-US" sz="1150" dirty="0"/>
           </a:p>

</xml_diff>

<commit_message>
Convenios: valor de mercado real de cataratas y precio municipio simplificado a 850k todo incluido
- Investigacion del valor particular de mercado de cataratas (fuentes 2025-2026):
  referencia conservadora ~1.200.000/ojo (rango 900k-1.500k).
- Precio al municipio simplificado: 850.000 por ojo TODO INCLUIDO (lente monofocal),
  ambos ojos; lente premium con copago de la diferencia. Ahorro ~29% vs mercado.
- Presentacion (slide economico): mercado 1.200.000 / Programa 850.000 / ahorro 29% /
  vecino 0; nota con fuente y mensaje 'el vecino recomienda'. PPTX y PDF sincronizados.
- Convenio v2, comparativa (md+pdf), PANEL y README actualizados.

Co-Authored-By: Claude Opus 4.8 <noreply@anthropic.com>
Claude-Session: https://claude.ai/code/session_01U3j1dNGqU3Tn9zZdTWjv1s
</commit_message>
<xml_diff>
--- a/convenios/ver-para-vivir/fuentes/Presentacion_Programa_Salud_Visual_Municipios.pptx
+++ b/convenios/ver-para-vivir/fuentes/Presentacion_Programa_Salud_Visual_Municipios.pptx
@@ -7129,7 +7129,7 @@
                 <a:ea typeface="Calibri" pitchFamily="34" charset="-122"/>
                 <a:cs typeface="Calibri" pitchFamily="34" charset="-120"/>
               </a:rPr>
-              <a:t>Rédito social y comunicacional concreto</a:t>
+              <a:t>El vecino que vuelve a ver agradece y recomienda la gestión</a:t>
             </a:r>
             <a:endParaRPr lang="en-US" sz="1300" dirty="0"/>
           </a:p>
@@ -9099,7 +9099,7 @@
                 <a:ea typeface="Cambria" pitchFamily="34" charset="-122"/>
                 <a:cs typeface="Cambria" pitchFamily="34" charset="-120"/>
               </a:rPr>
-              <a:t>Transparente y auditable: el municipio paga menos que el valor de mercado</a:t>
+              <a:t>El municipio paga bastante menos que el valor particular de mercado</a:t>
             </a:r>
             <a:endParaRPr lang="en-US" sz="2500" dirty="0"/>
           </a:p>
@@ -9138,7 +9138,7 @@
                 <a:ea typeface="Calibri" pitchFamily="34" charset="-122"/>
                 <a:cs typeface="Calibri" pitchFamily="34" charset="-120"/>
               </a:rPr>
-              <a:t>Cirugía de catarata — precios del Programa</a:t>
+              <a:t>Cirugía de catarata — por ojo, todo incluido (con lente monofocal)</a:t>
             </a:r>
             <a:endParaRPr lang="en-US" sz="1400" dirty="0"/>
           </a:p>
@@ -9199,7 +9199,7 @@
                 <a:ea typeface="Calibri" pitchFamily="34" charset="-122"/>
                 <a:cs typeface="Calibri" pitchFamily="34" charset="-120"/>
               </a:rPr>
-              <a:t>Valor de mercado (ref.)</a:t>
+              <a:t>Valor particular de mercado (ref.)</a:t>
             </a:r>
             <a:endParaRPr lang="en-US" sz="1350" dirty="0"/>
           </a:p>
@@ -9238,7 +9238,7 @@
                 <a:ea typeface="Cambria" pitchFamily="34" charset="-122"/>
                 <a:cs typeface="Cambria" pitchFamily="34" charset="-120"/>
               </a:rPr>
-              <a:t>$ 1.050.000</a:t>
+              <a:t>$ 1.200.000</a:t>
             </a:r>
             <a:endParaRPr lang="en-US" sz="1500" dirty="0"/>
           </a:p>
@@ -9299,7 +9299,7 @@
                 <a:ea typeface="Calibri" pitchFamily="34" charset="-122"/>
                 <a:cs typeface="Calibri" pitchFamily="34" charset="-120"/>
               </a:rPr>
-              <a:t>Precio Programa — con lente</a:t>
+              <a:t>Precio del Programa (por ojo)</a:t>
             </a:r>
             <a:endParaRPr lang="en-US" sz="1350" dirty="0"/>
           </a:p>
@@ -9338,7 +9338,7 @@
                 <a:ea typeface="Cambria" pitchFamily="34" charset="-122"/>
                 <a:cs typeface="Cambria" pitchFamily="34" charset="-120"/>
               </a:rPr>
-              <a:t>$ 1.000.000</a:t>
+              <a:t>$ 850.000</a:t>
             </a:r>
             <a:endParaRPr lang="en-US" sz="1500" dirty="0"/>
           </a:p>
@@ -9399,7 +9399,7 @@
                 <a:ea typeface="Calibri" pitchFamily="34" charset="-122"/>
                 <a:cs typeface="Calibri" pitchFamily="34" charset="-120"/>
               </a:rPr>
-              <a:t>Precio Programa — sin lente</a:t>
+              <a:t>Ahorro para el municipio</a:t>
             </a:r>
             <a:endParaRPr lang="en-US" sz="1350" dirty="0"/>
           </a:p>
@@ -9438,7 +9438,7 @@
                 <a:ea typeface="Cambria" pitchFamily="34" charset="-122"/>
                 <a:cs typeface="Cambria" pitchFamily="34" charset="-120"/>
               </a:rPr>
-              <a:t>$ 850.000</a:t>
+              <a:t>≈ 29%</a:t>
             </a:r>
             <a:endParaRPr lang="en-US" sz="1500" dirty="0"/>
           </a:p>
@@ -9580,7 +9580,7 @@
                 <a:ea typeface="Calibri" pitchFamily="34" charset="-122"/>
                 <a:cs typeface="Calibri" pitchFamily="34" charset="-120"/>
               </a:rPr>
-              <a:t>Precios finales con el descuento del Programa ya incluido. Con lente: $1.000.000 el 1.er ojo y $850.000 el 2.º ojo. Sin lente: $850.000 (lente a cargo del paciente).</a:t>
+              <a:t>Precio final con lente monofocal incluida, ambos ojos, con el descuento del Programa ya aplicado. Valor particular de mercado de referencia: cirugía con lente monofocal, todo incluido (fuentes 2025-2026; conviene respaldarlo con un presupuesto local). El vecino que recupera la vista agradece y recomienda el programa: rédito social y político para la gestión.</a:t>
             </a:r>
             <a:endParaRPr lang="en-US" sz="1250" dirty="0"/>
           </a:p>

</xml_diff>